<commit_message>
flysfly v14：721-3 補圖（Magnolia 疊印、Dragonfly、Insectes）；簡報第 3、11 張更新
Co-Authored-By: Claude Opus 5.5 <noreply@anthropic.com>
Claude-Session: https://claude.ai/code/session_019mRWBq9ZLkjTmRSxqecmgr
</commit_message>
<xml_diff>
--- a/flysfly/簡報/LIVE_1_48-1_20261021_Man_Ray_FlysFly_蜂飛記_鄭丁南20261021.pptx
+++ b/flysfly/簡報/LIVE_1_48-1_20261021_Man_Ray_FlysFly_蜂飛記_鄭丁南20261021.pptx
@@ -118,23 +118,23 @@
   <p:extLst>
     <p:ext uri="{521415D9-36F7-43E2-AB2F-B90AF26B5E84}">
       <p14:sectionLst xmlns:p14="http://schemas.microsoft.com/office/powerpoint/2010/main">
-        <p14:section name="封面" id="{bf658c73-9417-b414-ee9c-8ff5e5093a7f}">
+        <p14:section name="封面" id="{d31dbd14-6b32-ddd2-3e82-a6f0ed212034}">
           <p14:sldIdLst>
             <p14:sldId id="256"/>
           </p14:sldIdLst>
         </p14:section>
-        <p14:section name="前菜" id="{51f3f40f-4047-f44c-23e8-7ee756f3c7ec}">
+        <p14:section name="前菜" id="{31c8487d-4e8c-48f1-5d52-d019fc18596a}">
           <p14:sldIdLst>
             <p14:sldId id="257"/>
           </p14:sldIdLst>
         </p14:section>
-        <p14:section name="中場" id="{2693ff81-c648-feb3-cfc0-c20263daa846}">
+        <p14:section name="中場" id="{9e027911-2fab-482d-737e-01fb40f42ad4}">
           <p14:sldIdLst>
             <p14:sldId id="258"/>
             <p14:sldId id="259"/>
           </p14:sldIdLst>
         </p14:section>
-        <p14:section name="主菜" id="{35977073-1f21-1dde-e808-1aedcad7828b}">
+        <p14:section name="主菜" id="{192c9e45-2dc8-7846-95b7-7e7165d1a17c}">
           <p14:sldIdLst>
             <p14:sldId id="260"/>
             <p14:sldId id="261"/>
@@ -143,12 +143,12 @@
             <p14:sldId id="264"/>
           </p14:sldIdLst>
         </p14:section>
-        <p14:section name="甜點" id="{4ad584ff-fe8e-fb00-9868-556b134bf41d}">
+        <p14:section name="甜點" id="{8e177662-5da3-27ba-758e-6af329e077e9}">
           <p14:sldIdLst>
             <p14:sldId id="265"/>
           </p14:sldIdLst>
         </p14:section>
-        <p14:section name="彩蛋" id="{f630d93d-80ee-3833-b039-bd6d0227a7b1}">
+        <p14:section name="彩蛋" id="{4c330d6f-fd07-1b14-37a3-abb6fc781246}">
           <p14:sldIdLst>
             <p14:sldId id="266"/>
             <p14:sldId id="267"/>
@@ -743,7 +743,7 @@
 《Mouche》約 1930：p.244 的蜂底片。
 《Sauterelle》約 1945：Pompidou 蚱蜢底片，好萊塢時期，共 18 筆。
 《Untitled (For Immobility)》1947：五隻昆蟲擬態藏在枯枝落葉間的 shadow box，送給書籍裝幀家 Mary Reynolds；主題是昆蟲在眼前卻看不見。
-《Dragonfly》1926：《Revolving Doors》十張 pochoir 之一（MoMA）；《Insectes》vers 1930（André Breton 舊藏，背面 MR 花押）。這兩件沒有可用圖片。
+《Dragonfly》1926：《Revolving Doors》十張 pochoir 之一（圖：National Gallery of Art；MoMA 385.1988.10 同版）。《Insectes》vers 1930（André Breton 舊藏，背面 MR 花押）：一隻花潛金龜與一隻天牛，和 Met [Butterflies] 下緣的兩隻是同一批標本。
 「只有 p.244」是目前查到的範圍，不是定論；Steidl《Trees &amp; Flowers – Insects &amp; Animals》（2009）可能還有。</a:t>
             </a:r>
             <a:endParaRPr lang="en-US" dirty="0"/>
@@ -1018,7 +1018,7 @@
               <a:t>MFAH 2015.90：the artist experimented with a double exposure during the printing process by layering two negatives on top of each other.（在印相過程中把兩張底片疊在一起做雙重曝光。）
 BMA 1988.430《Marcel Duchamp》c.1920：Superimposition of two negatives。
 Sotheby’s 2017 Lot 118：two of Man Ray’s photographs are printed together…
-Duchamp 與 Magnolia 館方／拍賣頁沒有可用圖片，這裡只列文字。
+Phillips 2024 Lot 261《Magnolia Blossom, Paris》1926：疊印用的木蘭花原作之一。疊印版裡木蘭花呈暗色調、眼睛透在花瓣裡。Duchamp 的 BMA 館方頁沒有圖片，只列文字。
 重點：這些疊合是透明、互相滲透的「疊影」；p.244 的蜂則是實心剪影，用法不同。</a:t>
             </a:r>
             <a:endParaRPr lang="en-US" dirty="0"/>
@@ -3297,8 +3297,8 @@
         </p:blipFill>
         <p:spPr>
           <a:xfrm>
-            <a:off x="457200" y="2432907"/>
-            <a:ext cx="1755648" cy="986346"/>
+            <a:off x="457200" y="2553632"/>
+            <a:ext cx="1325880" cy="744897"/>
           </a:xfrm>
           <a:prstGeom prst="rect">
             <a:avLst/>
@@ -3313,7 +3313,7 @@
         </p:nvSpPr>
         <p:spPr>
           <a:xfrm>
-            <a:off x="1261872" y="4453128"/>
+            <a:off x="1046988" y="4453128"/>
             <a:ext cx="146304" cy="146304"/>
           </a:xfrm>
           <a:prstGeom prst="ellipse">
@@ -3338,8 +3338,8 @@
         </p:nvSpPr>
         <p:spPr>
           <a:xfrm>
-            <a:off x="457200" y="4645152"/>
-            <a:ext cx="1755648" cy="320040"/>
+            <a:off x="411480" y="4645152"/>
+            <a:ext cx="1417320" cy="320040"/>
           </a:xfrm>
           <a:prstGeom prst="rect">
             <a:avLst/>
@@ -3355,14 +3355,14 @@
               <a:buNone/>
             </a:pPr>
             <a:r>
-              <a:rPr lang="en-US" sz="1600" b="1" dirty="0">
+              <a:rPr lang="en-US" sz="1500" b="1" dirty="0">
                 <a:solidFill>
                   <a:srgbClr val="1C1B1D"/>
                 </a:solidFill>
               </a:rPr>
               <a:t>1922</a:t>
             </a:r>
-            <a:endParaRPr lang="en-US" sz="1600" dirty="0"/>
+            <a:endParaRPr lang="en-US" sz="1500" dirty="0"/>
           </a:p>
         </p:txBody>
       </p:sp>
@@ -3374,8 +3374,8 @@
         </p:nvSpPr>
         <p:spPr>
           <a:xfrm>
-            <a:off x="457200" y="4956048"/>
-            <a:ext cx="1755648" cy="274320"/>
+            <a:off x="411480" y="4956048"/>
+            <a:ext cx="1417320" cy="274320"/>
           </a:xfrm>
           <a:prstGeom prst="rect">
             <a:avLst/>
@@ -3391,14 +3391,14 @@
               <a:buNone/>
             </a:pPr>
             <a:r>
-              <a:rPr lang="en-US" sz="1200" dirty="0">
+              <a:rPr lang="en-US" sz="1100" dirty="0">
                 <a:solidFill>
                   <a:srgbClr val="1C1B1D"/>
                 </a:solidFill>
               </a:rPr>
               <a:t>Rayograph（局部）</a:t>
             </a:r>
-            <a:endParaRPr lang="en-US" sz="1200" dirty="0"/>
+            <a:endParaRPr lang="en-US" sz="1100" dirty="0"/>
           </a:p>
         </p:txBody>
       </p:sp>
@@ -3410,8 +3410,8 @@
         </p:nvSpPr>
         <p:spPr>
           <a:xfrm>
-            <a:off x="457200" y="5212080"/>
-            <a:ext cx="1755648" cy="274320"/>
+            <a:off x="411480" y="5212080"/>
+            <a:ext cx="1417320" cy="274320"/>
           </a:xfrm>
           <a:prstGeom prst="rect">
             <a:avLst/>
@@ -3427,20 +3427,20 @@
               <a:buNone/>
             </a:pPr>
             <a:r>
-              <a:rPr lang="en-US" sz="1000" dirty="0">
+              <a:rPr lang="en-US" sz="900" dirty="0">
                 <a:solidFill>
                   <a:srgbClr val="5F5D63"/>
                 </a:solidFill>
               </a:rPr>
-              <a:t>The Met 2025 大展主視覺</a:t>
-            </a:r>
-            <a:endParaRPr lang="en-US" sz="1000" dirty="0"/>
+              <a:t>The Met 大展主視覺</a:t>
+            </a:r>
+            <a:endParaRPr lang="en-US" sz="900" dirty="0"/>
           </a:p>
         </p:txBody>
       </p:sp>
       <p:pic>
         <p:nvPicPr>
-          <p:cNvPr id="10" name="[Butterflies]" descr="/tmp/claude-0/deck12/img/ffsl_manray_butterflies_met.jpg">    </p:cNvPr>
+          <p:cNvPr id="10" name="《Dragonfly》" descr="/tmp/claude-0/deck12/img/mr_dragonfly_nga.jpg">    </p:cNvPr>
           <p:cNvPicPr>
             <a:picLocks noChangeAspect="1"/>
           </p:cNvPicPr>
@@ -3454,8 +3454,8 @@
         </p:blipFill>
         <p:spPr>
           <a:xfrm>
-            <a:off x="2359152" y="2218252"/>
-            <a:ext cx="1755648" cy="1415656"/>
+            <a:off x="1879092" y="1966881"/>
+            <a:ext cx="1325880" cy="1918398"/>
           </a:xfrm>
           <a:prstGeom prst="rect">
             <a:avLst/>
@@ -3470,7 +3470,7 @@
         </p:nvSpPr>
         <p:spPr>
           <a:xfrm>
-            <a:off x="3163824" y="4453128"/>
+            <a:off x="2468880" y="4453128"/>
             <a:ext cx="146304" cy="146304"/>
           </a:xfrm>
           <a:prstGeom prst="ellipse">
@@ -3495,8 +3495,8 @@
         </p:nvSpPr>
         <p:spPr>
           <a:xfrm>
-            <a:off x="2359152" y="4645152"/>
-            <a:ext cx="1755648" cy="320040"/>
+            <a:off x="1833372" y="4645152"/>
+            <a:ext cx="1417320" cy="320040"/>
           </a:xfrm>
           <a:prstGeom prst="rect">
             <a:avLst/>
@@ -3512,14 +3512,14 @@
               <a:buNone/>
             </a:pPr>
             <a:r>
-              <a:rPr lang="en-US" sz="1600" b="1" dirty="0">
+              <a:rPr lang="en-US" sz="1500" b="1" dirty="0">
                 <a:solidFill>
                   <a:srgbClr val="1C1B1D"/>
                 </a:solidFill>
               </a:rPr>
-              <a:t>約 1930</a:t>
-            </a:r>
-            <a:endParaRPr lang="en-US" sz="1600" dirty="0"/>
+              <a:t>1926</a:t>
+            </a:r>
+            <a:endParaRPr lang="en-US" sz="1500" dirty="0"/>
           </a:p>
         </p:txBody>
       </p:sp>
@@ -3531,8 +3531,8 @@
         </p:nvSpPr>
         <p:spPr>
           <a:xfrm>
-            <a:off x="2359152" y="4956048"/>
-            <a:ext cx="1755648" cy="274320"/>
+            <a:off x="1833372" y="4956048"/>
+            <a:ext cx="1417320" cy="274320"/>
           </a:xfrm>
           <a:prstGeom prst="rect">
             <a:avLst/>
@@ -3548,14 +3548,14 @@
               <a:buNone/>
             </a:pPr>
             <a:r>
-              <a:rPr lang="en-US" sz="1200" dirty="0">
+              <a:rPr lang="en-US" sz="1100" dirty="0">
                 <a:solidFill>
                   <a:srgbClr val="1C1B1D"/>
                 </a:solidFill>
               </a:rPr>
-              <a:t>[Butterflies]</a:t>
-            </a:r>
-            <a:endParaRPr lang="en-US" sz="1200" dirty="0"/>
+              <a:t>《Dragonfly》</a:t>
+            </a:r>
+            <a:endParaRPr lang="en-US" sz="1100" dirty="0"/>
           </a:p>
         </p:txBody>
       </p:sp>
@@ -3567,8 +3567,8 @@
         </p:nvSpPr>
         <p:spPr>
           <a:xfrm>
-            <a:off x="2359152" y="5212080"/>
-            <a:ext cx="1755648" cy="274320"/>
+            <a:off x="1833372" y="5212080"/>
+            <a:ext cx="1417320" cy="274320"/>
           </a:xfrm>
           <a:prstGeom prst="rect">
             <a:avLst/>
@@ -3584,20 +3584,20 @@
               <a:buNone/>
             </a:pPr>
             <a:r>
-              <a:rPr lang="en-US" sz="1000" dirty="0">
+              <a:rPr lang="en-US" sz="900" dirty="0">
                 <a:solidFill>
                   <a:srgbClr val="5F5D63"/>
                 </a:solidFill>
               </a:rPr>
-              <a:t>The Met 1977.539</a:t>
-            </a:r>
-            <a:endParaRPr lang="en-US" sz="1000" dirty="0"/>
+              <a:t>NGA</a:t>
+            </a:r>
+            <a:endParaRPr lang="en-US" sz="900" dirty="0"/>
           </a:p>
         </p:txBody>
       </p:sp>
       <p:pic>
         <p:nvPicPr>
-          <p:cNvPr id="15" name="《Mouche》蜂底片" descr="/tmp/claude-0/deck12/img/v82_pomp4543_pos.jpg">    </p:cNvPr>
+          <p:cNvPr id="15" name="[Butterflies]" descr="/tmp/claude-0/deck12/img/ffsl_manray_butterflies_met.jpg">    </p:cNvPr>
           <p:cNvPicPr>
             <a:picLocks noChangeAspect="1"/>
           </p:cNvPicPr>
@@ -3611,8 +3611,8 @@
         </p:blipFill>
         <p:spPr>
           <a:xfrm>
-            <a:off x="4261104" y="2298436"/>
-            <a:ext cx="1755648" cy="1255288"/>
+            <a:off x="3300984" y="2391522"/>
+            <a:ext cx="1325880" cy="1069115"/>
           </a:xfrm>
           <a:prstGeom prst="rect">
             <a:avLst/>
@@ -3621,14 +3621,328 @@
       </p:pic>
       <p:sp>
         <p:nvSpPr>
-          <p:cNvPr id="16" name="蜂 紅框"/>
+          <p:cNvPr id="16" name="dot2"/>
           <p:cNvSpPr/>
           <p:nvPr/>
         </p:nvSpPr>
         <p:spPr>
           <a:xfrm>
-            <a:off x="4215384" y="2252716"/>
-            <a:ext cx="1847088" cy="1346728"/>
+            <a:off x="3890772" y="4453128"/>
+            <a:ext cx="146304" cy="146304"/>
+          </a:xfrm>
+          <a:prstGeom prst="ellipse">
+            <a:avLst/>
+          </a:prstGeom>
+          <a:solidFill>
+            <a:srgbClr val="8A877F"/>
+          </a:solidFill>
+          <a:ln w="12700">
+            <a:solidFill>
+              <a:srgbClr val="8A877F"/>
+            </a:solidFill>
+            <a:prstDash val="solid"/>
+          </a:ln>
+        </p:spPr>
+      </p:sp>
+      <p:sp>
+        <p:nvSpPr>
+          <p:cNvPr id="17" name="yr2"/>
+          <p:cNvSpPr txBox="1"/>
+          <p:nvPr/>
+        </p:nvSpPr>
+        <p:spPr>
+          <a:xfrm>
+            <a:off x="3255264" y="4645152"/>
+            <a:ext cx="1417320" cy="320040"/>
+          </a:xfrm>
+          <a:prstGeom prst="rect">
+            <a:avLst/>
+          </a:prstGeom>
+          <a:noFill/>
+          <a:ln/>
+        </p:spPr>
+        <p:txBody>
+          <a:bodyPr wrap="square" lIns="0" tIns="0" rIns="0" bIns="0" rtlCol="0" anchor="ctr"/>
+          <a:lstStyle/>
+          <a:p>
+            <a:pPr algn="ctr" indent="0" marL="0">
+              <a:buNone/>
+            </a:pPr>
+            <a:r>
+              <a:rPr lang="en-US" sz="1500" b="1" dirty="0">
+                <a:solidFill>
+                  <a:srgbClr val="1C1B1D"/>
+                </a:solidFill>
+              </a:rPr>
+              <a:t>約 1930</a:t>
+            </a:r>
+            <a:endParaRPr lang="en-US" sz="1500" dirty="0"/>
+          </a:p>
+        </p:txBody>
+      </p:sp>
+      <p:sp>
+        <p:nvSpPr>
+          <p:cNvPr id="18" name="caption"/>
+          <p:cNvSpPr txBox="1"/>
+          <p:nvPr/>
+        </p:nvSpPr>
+        <p:spPr>
+          <a:xfrm>
+            <a:off x="3255264" y="4956048"/>
+            <a:ext cx="1417320" cy="274320"/>
+          </a:xfrm>
+          <a:prstGeom prst="rect">
+            <a:avLst/>
+          </a:prstGeom>
+          <a:noFill/>
+          <a:ln/>
+        </p:spPr>
+        <p:txBody>
+          <a:bodyPr wrap="square" lIns="0" tIns="0" rIns="0" bIns="0" rtlCol="0" anchor="t"/>
+          <a:lstStyle/>
+          <a:p>
+            <a:pPr algn="ctr" indent="0" marL="0">
+              <a:buNone/>
+            </a:pPr>
+            <a:r>
+              <a:rPr lang="en-US" sz="1100" dirty="0">
+                <a:solidFill>
+                  <a:srgbClr val="1C1B1D"/>
+                </a:solidFill>
+              </a:rPr>
+              <a:t>[Butterflies]</a:t>
+            </a:r>
+            <a:endParaRPr lang="en-US" sz="1100" dirty="0"/>
+          </a:p>
+        </p:txBody>
+      </p:sp>
+      <p:sp>
+        <p:nvSpPr>
+          <p:cNvPr id="19" name="caption"/>
+          <p:cNvSpPr txBox="1"/>
+          <p:nvPr/>
+        </p:nvSpPr>
+        <p:spPr>
+          <a:xfrm>
+            <a:off x="3255264" y="5212080"/>
+            <a:ext cx="1417320" cy="274320"/>
+          </a:xfrm>
+          <a:prstGeom prst="rect">
+            <a:avLst/>
+          </a:prstGeom>
+          <a:noFill/>
+          <a:ln/>
+        </p:spPr>
+        <p:txBody>
+          <a:bodyPr wrap="square" lIns="0" tIns="0" rIns="0" bIns="0" rtlCol="0" anchor="t"/>
+          <a:lstStyle/>
+          <a:p>
+            <a:pPr algn="ctr" indent="0" marL="0">
+              <a:buNone/>
+            </a:pPr>
+            <a:r>
+              <a:rPr lang="en-US" sz="900" dirty="0">
+                <a:solidFill>
+                  <a:srgbClr val="5F5D63"/>
+                </a:solidFill>
+              </a:rPr>
+              <a:t>The Met 1977.539</a:t>
+            </a:r>
+            <a:endParaRPr lang="en-US" sz="900" dirty="0"/>
+          </a:p>
+        </p:txBody>
+      </p:sp>
+      <p:pic>
+        <p:nvPicPr>
+          <p:cNvPr id="20" name="《Insectes》" descr="/tmp/claude-0/deck12/img/mr_insectes_breton.jpg">    </p:cNvPr>
+          <p:cNvPicPr>
+            <a:picLocks noChangeAspect="1"/>
+          </p:cNvPicPr>
+          <p:nvPr/>
+        </p:nvPicPr>
+        <p:blipFill>
+          <a:blip r:embed="rId4"/>
+          <a:stretch>
+            <a:fillRect/>
+          </a:stretch>
+        </p:blipFill>
+        <p:spPr>
+          <a:xfrm>
+            <a:off x="4722876" y="2467178"/>
+            <a:ext cx="1325880" cy="917804"/>
+          </a:xfrm>
+          <a:prstGeom prst="rect">
+            <a:avLst/>
+          </a:prstGeom>
+        </p:spPr>
+      </p:pic>
+      <p:sp>
+        <p:nvSpPr>
+          <p:cNvPr id="21" name="dot3"/>
+          <p:cNvSpPr/>
+          <p:nvPr/>
+        </p:nvSpPr>
+        <p:spPr>
+          <a:xfrm>
+            <a:off x="5312664" y="4453128"/>
+            <a:ext cx="146304" cy="146304"/>
+          </a:xfrm>
+          <a:prstGeom prst="ellipse">
+            <a:avLst/>
+          </a:prstGeom>
+          <a:solidFill>
+            <a:srgbClr val="8A877F"/>
+          </a:solidFill>
+          <a:ln w="12700">
+            <a:solidFill>
+              <a:srgbClr val="8A877F"/>
+            </a:solidFill>
+            <a:prstDash val="solid"/>
+          </a:ln>
+        </p:spPr>
+      </p:sp>
+      <p:sp>
+        <p:nvSpPr>
+          <p:cNvPr id="22" name="yr3"/>
+          <p:cNvSpPr txBox="1"/>
+          <p:nvPr/>
+        </p:nvSpPr>
+        <p:spPr>
+          <a:xfrm>
+            <a:off x="4677156" y="4645152"/>
+            <a:ext cx="1417320" cy="320040"/>
+          </a:xfrm>
+          <a:prstGeom prst="rect">
+            <a:avLst/>
+          </a:prstGeom>
+          <a:noFill/>
+          <a:ln/>
+        </p:spPr>
+        <p:txBody>
+          <a:bodyPr wrap="square" lIns="0" tIns="0" rIns="0" bIns="0" rtlCol="0" anchor="ctr"/>
+          <a:lstStyle/>
+          <a:p>
+            <a:pPr algn="ctr" indent="0" marL="0">
+              <a:buNone/>
+            </a:pPr>
+            <a:r>
+              <a:rPr lang="en-US" sz="1500" b="1" dirty="0">
+                <a:solidFill>
+                  <a:srgbClr val="1C1B1D"/>
+                </a:solidFill>
+              </a:rPr>
+              <a:t>約 1930</a:t>
+            </a:r>
+            <a:endParaRPr lang="en-US" sz="1500" dirty="0"/>
+          </a:p>
+        </p:txBody>
+      </p:sp>
+      <p:sp>
+        <p:nvSpPr>
+          <p:cNvPr id="23" name="caption"/>
+          <p:cNvSpPr txBox="1"/>
+          <p:nvPr/>
+        </p:nvSpPr>
+        <p:spPr>
+          <a:xfrm>
+            <a:off x="4677156" y="4956048"/>
+            <a:ext cx="1417320" cy="274320"/>
+          </a:xfrm>
+          <a:prstGeom prst="rect">
+            <a:avLst/>
+          </a:prstGeom>
+          <a:noFill/>
+          <a:ln/>
+        </p:spPr>
+        <p:txBody>
+          <a:bodyPr wrap="square" lIns="0" tIns="0" rIns="0" bIns="0" rtlCol="0" anchor="t"/>
+          <a:lstStyle/>
+          <a:p>
+            <a:pPr algn="ctr" indent="0" marL="0">
+              <a:buNone/>
+            </a:pPr>
+            <a:r>
+              <a:rPr lang="en-US" sz="1100" dirty="0">
+                <a:solidFill>
+                  <a:srgbClr val="1C1B1D"/>
+                </a:solidFill>
+              </a:rPr>
+              <a:t>《Insectes》</a:t>
+            </a:r>
+            <a:endParaRPr lang="en-US" sz="1100" dirty="0"/>
+          </a:p>
+        </p:txBody>
+      </p:sp>
+      <p:sp>
+        <p:nvSpPr>
+          <p:cNvPr id="24" name="caption"/>
+          <p:cNvSpPr txBox="1"/>
+          <p:nvPr/>
+        </p:nvSpPr>
+        <p:spPr>
+          <a:xfrm>
+            <a:off x="4677156" y="5212080"/>
+            <a:ext cx="1417320" cy="274320"/>
+          </a:xfrm>
+          <a:prstGeom prst="rect">
+            <a:avLst/>
+          </a:prstGeom>
+          <a:noFill/>
+          <a:ln/>
+        </p:spPr>
+        <p:txBody>
+          <a:bodyPr wrap="square" lIns="0" tIns="0" rIns="0" bIns="0" rtlCol="0" anchor="t"/>
+          <a:lstStyle/>
+          <a:p>
+            <a:pPr algn="ctr" indent="0" marL="0">
+              <a:buNone/>
+            </a:pPr>
+            <a:r>
+              <a:rPr lang="en-US" sz="900" dirty="0">
+                <a:solidFill>
+                  <a:srgbClr val="5F5D63"/>
+                </a:solidFill>
+              </a:rPr>
+              <a:t>André Breton 舊藏</a:t>
+            </a:r>
+            <a:endParaRPr lang="en-US" sz="900" dirty="0"/>
+          </a:p>
+        </p:txBody>
+      </p:sp>
+      <p:pic>
+        <p:nvPicPr>
+          <p:cNvPr id="25" name="《Mouche》蜂底片" descr="/tmp/claude-0/deck12/img/v82_pomp4543_pos.jpg">    </p:cNvPr>
+          <p:cNvPicPr>
+            <a:picLocks noChangeAspect="1"/>
+          </p:cNvPicPr>
+          <p:nvPr/>
+        </p:nvPicPr>
+        <p:blipFill>
+          <a:blip r:embed="rId5"/>
+          <a:stretch>
+            <a:fillRect/>
+          </a:stretch>
+        </p:blipFill>
+        <p:spPr>
+          <a:xfrm>
+            <a:off x="6144768" y="2452078"/>
+            <a:ext cx="1325880" cy="948004"/>
+          </a:xfrm>
+          <a:prstGeom prst="rect">
+            <a:avLst/>
+          </a:prstGeom>
+        </p:spPr>
+      </p:pic>
+      <p:sp>
+        <p:nvSpPr>
+          <p:cNvPr id="26" name="蜂 紅框"/>
+          <p:cNvSpPr/>
+          <p:nvPr/>
+        </p:nvSpPr>
+        <p:spPr>
+          <a:xfrm>
+            <a:off x="6099048" y="2406358"/>
+            <a:ext cx="1417320" cy="1039444"/>
           </a:xfrm>
           <a:prstGeom prst="rect">
             <a:avLst/>
@@ -3643,13 +3957,13 @@
       </p:sp>
       <p:sp>
         <p:nvSpPr>
-          <p:cNvPr id="17" name="dot2"/>
+          <p:cNvPr id="27" name="dot4"/>
           <p:cNvSpPr/>
           <p:nvPr/>
         </p:nvSpPr>
         <p:spPr>
           <a:xfrm>
-            <a:off x="5065776" y="4453128"/>
+            <a:off x="6734556" y="4453128"/>
             <a:ext cx="146304" cy="146304"/>
           </a:xfrm>
           <a:prstGeom prst="ellipse">
@@ -3668,14 +3982,14 @@
       </p:sp>
       <p:sp>
         <p:nvSpPr>
-          <p:cNvPr id="18" name="yr2"/>
-          <p:cNvSpPr txBox="1"/>
-          <p:nvPr/>
-        </p:nvSpPr>
-        <p:spPr>
-          <a:xfrm>
-            <a:off x="4261104" y="4645152"/>
-            <a:ext cx="1755648" cy="320040"/>
+          <p:cNvPr id="28" name="yr4"/>
+          <p:cNvSpPr txBox="1"/>
+          <p:nvPr/>
+        </p:nvSpPr>
+        <p:spPr>
+          <a:xfrm>
+            <a:off x="6099048" y="4645152"/>
+            <a:ext cx="1417320" cy="320040"/>
           </a:xfrm>
           <a:prstGeom prst="rect">
             <a:avLst/>
@@ -3691,27 +4005,27 @@
               <a:buNone/>
             </a:pPr>
             <a:r>
-              <a:rPr lang="en-US" sz="1600" b="1" dirty="0">
+              <a:rPr lang="en-US" sz="1500" b="1" dirty="0">
                 <a:solidFill>
                   <a:srgbClr val="A8321F"/>
                 </a:solidFill>
               </a:rPr>
               <a:t>約 1930</a:t>
             </a:r>
-            <a:endParaRPr lang="en-US" sz="1600" dirty="0"/>
-          </a:p>
-        </p:txBody>
-      </p:sp>
-      <p:sp>
-        <p:nvSpPr>
-          <p:cNvPr id="19" name="caption"/>
-          <p:cNvSpPr txBox="1"/>
-          <p:nvPr/>
-        </p:nvSpPr>
-        <p:spPr>
-          <a:xfrm>
-            <a:off x="4261104" y="4956048"/>
-            <a:ext cx="1755648" cy="274320"/>
+            <a:endParaRPr lang="en-US" sz="1500" dirty="0"/>
+          </a:p>
+        </p:txBody>
+      </p:sp>
+      <p:sp>
+        <p:nvSpPr>
+          <p:cNvPr id="29" name="caption"/>
+          <p:cNvSpPr txBox="1"/>
+          <p:nvPr/>
+        </p:nvSpPr>
+        <p:spPr>
+          <a:xfrm>
+            <a:off x="6099048" y="4956048"/>
+            <a:ext cx="1417320" cy="274320"/>
           </a:xfrm>
           <a:prstGeom prst="rect">
             <a:avLst/>
@@ -3727,27 +4041,27 @@
               <a:buNone/>
             </a:pPr>
             <a:r>
-              <a:rPr lang="en-US" sz="1200" dirty="0">
+              <a:rPr lang="en-US" sz="1100" dirty="0">
                 <a:solidFill>
                   <a:srgbClr val="1C1B1D"/>
                 </a:solidFill>
               </a:rPr>
               <a:t>《Mouche》蜂底片</a:t>
             </a:r>
-            <a:endParaRPr lang="en-US" sz="1200" dirty="0"/>
-          </a:p>
-        </p:txBody>
-      </p:sp>
-      <p:sp>
-        <p:nvSpPr>
-          <p:cNvPr id="20" name="caption"/>
-          <p:cNvSpPr txBox="1"/>
-          <p:nvPr/>
-        </p:nvSpPr>
-        <p:spPr>
-          <a:xfrm>
-            <a:off x="4261104" y="5212080"/>
-            <a:ext cx="1755648" cy="274320"/>
+            <a:endParaRPr lang="en-US" sz="1100" dirty="0"/>
+          </a:p>
+        </p:txBody>
+      </p:sp>
+      <p:sp>
+        <p:nvSpPr>
+          <p:cNvPr id="30" name="caption"/>
+          <p:cNvSpPr txBox="1"/>
+          <p:nvPr/>
+        </p:nvSpPr>
+        <p:spPr>
+          <a:xfrm>
+            <a:off x="6099048" y="5212080"/>
+            <a:ext cx="1417320" cy="274320"/>
           </a:xfrm>
           <a:prstGeom prst="rect">
             <a:avLst/>
@@ -3763,35 +4077,35 @@
               <a:buNone/>
             </a:pPr>
             <a:r>
-              <a:rPr lang="en-US" sz="1000" dirty="0">
+              <a:rPr lang="en-US" sz="900" dirty="0">
                 <a:solidFill>
                   <a:srgbClr val="5F5D63"/>
                 </a:solidFill>
               </a:rPr>
               <a:t>Pompidou</a:t>
             </a:r>
-            <a:endParaRPr lang="en-US" sz="1000" dirty="0"/>
+            <a:endParaRPr lang="en-US" sz="900" dirty="0"/>
           </a:p>
         </p:txBody>
       </p:sp>
       <p:pic>
         <p:nvPicPr>
-          <p:cNvPr id="21" name="《Butterflies》" descr="/tmp/claude-0/deck12/img/p242.jpg">    </p:cNvPr>
+          <p:cNvPr id="31" name="《Butterflies》" descr="/tmp/claude-0/deck12/img/p242.jpg">    </p:cNvPr>
           <p:cNvPicPr>
             <a:picLocks noChangeAspect="1"/>
           </p:cNvPicPr>
           <p:nvPr/>
         </p:nvPicPr>
         <p:blipFill>
-          <a:blip r:embed="rId4"/>
+          <a:blip r:embed="rId6"/>
           <a:stretch>
             <a:fillRect/>
           </a:stretch>
         </p:blipFill>
         <p:spPr>
           <a:xfrm>
-            <a:off x="6163056" y="2384577"/>
-            <a:ext cx="1755648" cy="1083005"/>
+            <a:off x="7566660" y="2517133"/>
+            <a:ext cx="1325880" cy="817895"/>
           </a:xfrm>
           <a:prstGeom prst="rect">
             <a:avLst/>
@@ -3800,13 +4114,13 @@
       </p:pic>
       <p:sp>
         <p:nvSpPr>
-          <p:cNvPr id="22" name="dot3"/>
+          <p:cNvPr id="32" name="dot5"/>
           <p:cNvSpPr/>
           <p:nvPr/>
         </p:nvSpPr>
         <p:spPr>
           <a:xfrm>
-            <a:off x="6967728" y="4453128"/>
+            <a:off x="8156448" y="4453128"/>
             <a:ext cx="146304" cy="146304"/>
           </a:xfrm>
           <a:prstGeom prst="ellipse">
@@ -3825,14 +4139,14 @@
       </p:sp>
       <p:sp>
         <p:nvSpPr>
-          <p:cNvPr id="23" name="yr3"/>
-          <p:cNvSpPr txBox="1"/>
-          <p:nvPr/>
-        </p:nvSpPr>
-        <p:spPr>
-          <a:xfrm>
-            <a:off x="6163056" y="4645152"/>
-            <a:ext cx="1755648" cy="320040"/>
+          <p:cNvPr id="33" name="yr5"/>
+          <p:cNvSpPr txBox="1"/>
+          <p:nvPr/>
+        </p:nvSpPr>
+        <p:spPr>
+          <a:xfrm>
+            <a:off x="7520940" y="4645152"/>
+            <a:ext cx="1417320" cy="320040"/>
           </a:xfrm>
           <a:prstGeom prst="rect">
             <a:avLst/>
@@ -3848,27 +4162,27 @@
               <a:buNone/>
             </a:pPr>
             <a:r>
-              <a:rPr lang="en-US" sz="1600" b="1" dirty="0">
+              <a:rPr lang="en-US" sz="1500" b="1" dirty="0">
                 <a:solidFill>
                   <a:srgbClr val="1C1B1D"/>
                 </a:solidFill>
               </a:rPr>
               <a:t>1935</a:t>
             </a:r>
-            <a:endParaRPr lang="en-US" sz="1600" dirty="0"/>
-          </a:p>
-        </p:txBody>
-      </p:sp>
-      <p:sp>
-        <p:nvSpPr>
-          <p:cNvPr id="24" name="caption"/>
-          <p:cNvSpPr txBox="1"/>
-          <p:nvPr/>
-        </p:nvSpPr>
-        <p:spPr>
-          <a:xfrm>
-            <a:off x="6163056" y="4956048"/>
-            <a:ext cx="1755648" cy="274320"/>
+            <a:endParaRPr lang="en-US" sz="1500" dirty="0"/>
+          </a:p>
+        </p:txBody>
+      </p:sp>
+      <p:sp>
+        <p:nvSpPr>
+          <p:cNvPr id="34" name="caption"/>
+          <p:cNvSpPr txBox="1"/>
+          <p:nvPr/>
+        </p:nvSpPr>
+        <p:spPr>
+          <a:xfrm>
+            <a:off x="7520940" y="4956048"/>
+            <a:ext cx="1417320" cy="274320"/>
           </a:xfrm>
           <a:prstGeom prst="rect">
             <a:avLst/>
@@ -3884,27 +4198,27 @@
               <a:buNone/>
             </a:pPr>
             <a:r>
-              <a:rPr lang="en-US" sz="1200" dirty="0">
+              <a:rPr lang="en-US" sz="1100" dirty="0">
                 <a:solidFill>
                   <a:srgbClr val="1C1B1D"/>
                 </a:solidFill>
               </a:rPr>
               <a:t>《Butterflies》</a:t>
             </a:r>
-            <a:endParaRPr lang="en-US" sz="1200" dirty="0"/>
-          </a:p>
-        </p:txBody>
-      </p:sp>
-      <p:sp>
-        <p:nvSpPr>
-          <p:cNvPr id="25" name="caption"/>
-          <p:cNvSpPr txBox="1"/>
-          <p:nvPr/>
-        </p:nvSpPr>
-        <p:spPr>
-          <a:xfrm>
-            <a:off x="6163056" y="5212080"/>
-            <a:ext cx="1755648" cy="274320"/>
+            <a:endParaRPr lang="en-US" sz="1100" dirty="0"/>
+          </a:p>
+        </p:txBody>
+      </p:sp>
+      <p:sp>
+        <p:nvSpPr>
+          <p:cNvPr id="35" name="caption"/>
+          <p:cNvSpPr txBox="1"/>
+          <p:nvPr/>
+        </p:nvSpPr>
+        <p:spPr>
+          <a:xfrm>
+            <a:off x="7520940" y="5212080"/>
+            <a:ext cx="1417320" cy="274320"/>
           </a:xfrm>
           <a:prstGeom prst="rect">
             <a:avLst/>
@@ -3920,35 +4234,35 @@
               <a:buNone/>
             </a:pPr>
             <a:r>
-              <a:rPr lang="en-US" sz="1000" dirty="0">
+              <a:rPr lang="en-US" sz="900" dirty="0">
                 <a:solidFill>
                   <a:srgbClr val="5F5D63"/>
                 </a:solidFill>
               </a:rPr>
               <a:t>研究素材 p.242</a:t>
             </a:r>
-            <a:endParaRPr lang="en-US" sz="1000" dirty="0"/>
+            <a:endParaRPr lang="en-US" sz="900" dirty="0"/>
           </a:p>
         </p:txBody>
       </p:sp>
       <p:pic>
         <p:nvPicPr>
-          <p:cNvPr id="26" name="《Sauterelle》蚱蜢" descr="/tmp/claude-0/deck12/img/pomp4553_sauterelle_inv.jpg">    </p:cNvPr>
+          <p:cNvPr id="36" name="《Sauterelle》" descr="/tmp/claude-0/deck12/img/pomp4553_sauterelle_inv.jpg">    </p:cNvPr>
           <p:cNvPicPr>
             <a:picLocks noChangeAspect="1"/>
           </p:cNvPicPr>
           <p:nvPr/>
         </p:nvPicPr>
         <p:blipFill>
-          <a:blip r:embed="rId5"/>
+          <a:blip r:embed="rId7"/>
           <a:stretch>
             <a:fillRect/>
           </a:stretch>
         </p:blipFill>
         <p:spPr>
           <a:xfrm>
-            <a:off x="8065008" y="2350954"/>
-            <a:ext cx="1755648" cy="1150252"/>
+            <a:off x="8988552" y="2491740"/>
+            <a:ext cx="1325880" cy="868680"/>
           </a:xfrm>
           <a:prstGeom prst="rect">
             <a:avLst/>
@@ -3957,13 +4271,13 @@
       </p:pic>
       <p:sp>
         <p:nvSpPr>
-          <p:cNvPr id="27" name="dot4"/>
+          <p:cNvPr id="37" name="dot6"/>
           <p:cNvSpPr/>
           <p:nvPr/>
         </p:nvSpPr>
         <p:spPr>
           <a:xfrm>
-            <a:off x="8869680" y="4453128"/>
+            <a:off x="9578340" y="4453128"/>
             <a:ext cx="146304" cy="146304"/>
           </a:xfrm>
           <a:prstGeom prst="ellipse">
@@ -3982,14 +4296,14 @@
       </p:sp>
       <p:sp>
         <p:nvSpPr>
-          <p:cNvPr id="28" name="yr4"/>
-          <p:cNvSpPr txBox="1"/>
-          <p:nvPr/>
-        </p:nvSpPr>
-        <p:spPr>
-          <a:xfrm>
-            <a:off x="8065008" y="4645152"/>
-            <a:ext cx="1755648" cy="320040"/>
+          <p:cNvPr id="38" name="yr6"/>
+          <p:cNvSpPr txBox="1"/>
+          <p:nvPr/>
+        </p:nvSpPr>
+        <p:spPr>
+          <a:xfrm>
+            <a:off x="8942832" y="4645152"/>
+            <a:ext cx="1417320" cy="320040"/>
           </a:xfrm>
           <a:prstGeom prst="rect">
             <a:avLst/>
@@ -4005,27 +4319,27 @@
               <a:buNone/>
             </a:pPr>
             <a:r>
-              <a:rPr lang="en-US" sz="1600" b="1" dirty="0">
+              <a:rPr lang="en-US" sz="1500" b="1" dirty="0">
                 <a:solidFill>
                   <a:srgbClr val="1C1B1D"/>
                 </a:solidFill>
               </a:rPr>
               <a:t>約 1945</a:t>
             </a:r>
-            <a:endParaRPr lang="en-US" sz="1600" dirty="0"/>
-          </a:p>
-        </p:txBody>
-      </p:sp>
-      <p:sp>
-        <p:nvSpPr>
-          <p:cNvPr id="29" name="caption"/>
-          <p:cNvSpPr txBox="1"/>
-          <p:nvPr/>
-        </p:nvSpPr>
-        <p:spPr>
-          <a:xfrm>
-            <a:off x="8065008" y="4956048"/>
-            <a:ext cx="1755648" cy="274320"/>
+            <a:endParaRPr lang="en-US" sz="1500" dirty="0"/>
+          </a:p>
+        </p:txBody>
+      </p:sp>
+      <p:sp>
+        <p:nvSpPr>
+          <p:cNvPr id="39" name="caption"/>
+          <p:cNvSpPr txBox="1"/>
+          <p:nvPr/>
+        </p:nvSpPr>
+        <p:spPr>
+          <a:xfrm>
+            <a:off x="8942832" y="4956048"/>
+            <a:ext cx="1417320" cy="274320"/>
           </a:xfrm>
           <a:prstGeom prst="rect">
             <a:avLst/>
@@ -4041,27 +4355,27 @@
               <a:buNone/>
             </a:pPr>
             <a:r>
-              <a:rPr lang="en-US" sz="1200" dirty="0">
+              <a:rPr lang="en-US" sz="1100" dirty="0">
                 <a:solidFill>
                   <a:srgbClr val="1C1B1D"/>
                 </a:solidFill>
               </a:rPr>
-              <a:t>《Sauterelle》蚱蜢</a:t>
-            </a:r>
-            <a:endParaRPr lang="en-US" sz="1200" dirty="0"/>
-          </a:p>
-        </p:txBody>
-      </p:sp>
-      <p:sp>
-        <p:nvSpPr>
-          <p:cNvPr id="30" name="caption"/>
-          <p:cNvSpPr txBox="1"/>
-          <p:nvPr/>
-        </p:nvSpPr>
-        <p:spPr>
-          <a:xfrm>
-            <a:off x="8065008" y="5212080"/>
-            <a:ext cx="1755648" cy="274320"/>
+              <a:t>《Sauterelle》</a:t>
+            </a:r>
+            <a:endParaRPr lang="en-US" sz="1100" dirty="0"/>
+          </a:p>
+        </p:txBody>
+      </p:sp>
+      <p:sp>
+        <p:nvSpPr>
+          <p:cNvPr id="40" name="caption"/>
+          <p:cNvSpPr txBox="1"/>
+          <p:nvPr/>
+        </p:nvSpPr>
+        <p:spPr>
+          <a:xfrm>
+            <a:off x="8942832" y="5212080"/>
+            <a:ext cx="1417320" cy="274320"/>
           </a:xfrm>
           <a:prstGeom prst="rect">
             <a:avLst/>
@@ -4077,35 +4391,35 @@
               <a:buNone/>
             </a:pPr>
             <a:r>
-              <a:rPr lang="en-US" sz="1000" dirty="0">
+              <a:rPr lang="en-US" sz="900" dirty="0">
                 <a:solidFill>
                   <a:srgbClr val="5F5D63"/>
                 </a:solidFill>
               </a:rPr>
               <a:t>Pompidou（反相）</a:t>
             </a:r>
-            <a:endParaRPr lang="en-US" sz="1000" dirty="0"/>
+            <a:endParaRPr lang="en-US" sz="900" dirty="0"/>
           </a:p>
         </p:txBody>
       </p:sp>
       <p:pic>
         <p:nvPicPr>
-          <p:cNvPr id="31" name="《For Immobility》" descr="/tmp/claude-0/deck12/img/ffsl_manray_for_immobility_aic.jpg">    </p:cNvPr>
+          <p:cNvPr id="41" name="《For Immobility》" descr="/tmp/claude-0/deck12/img/ffsl_manray_for_immobility_aic.jpg">    </p:cNvPr>
           <p:cNvPicPr>
             <a:picLocks noChangeAspect="1"/>
           </p:cNvPicPr>
           <p:nvPr/>
         </p:nvPicPr>
         <p:blipFill>
-          <a:blip r:embed="rId6"/>
+          <a:blip r:embed="rId8"/>
           <a:stretch>
             <a:fillRect/>
           </a:stretch>
         </p:blipFill>
         <p:spPr>
           <a:xfrm>
-            <a:off x="9966960" y="2300224"/>
-            <a:ext cx="1755648" cy="1251712"/>
+            <a:off x="10410444" y="2453428"/>
+            <a:ext cx="1325880" cy="945303"/>
           </a:xfrm>
           <a:prstGeom prst="rect">
             <a:avLst/>
@@ -4114,13 +4428,13 @@
       </p:pic>
       <p:sp>
         <p:nvSpPr>
-          <p:cNvPr id="32" name="dot5"/>
+          <p:cNvPr id="42" name="dot7"/>
           <p:cNvSpPr/>
           <p:nvPr/>
         </p:nvSpPr>
         <p:spPr>
           <a:xfrm>
-            <a:off x="10771632" y="4453128"/>
+            <a:off x="11000232" y="4453128"/>
             <a:ext cx="146304" cy="146304"/>
           </a:xfrm>
           <a:prstGeom prst="ellipse">
@@ -4139,14 +4453,14 @@
       </p:sp>
       <p:sp>
         <p:nvSpPr>
-          <p:cNvPr id="33" name="yr5"/>
-          <p:cNvSpPr txBox="1"/>
-          <p:nvPr/>
-        </p:nvSpPr>
-        <p:spPr>
-          <a:xfrm>
-            <a:off x="9966960" y="4645152"/>
-            <a:ext cx="1755648" cy="320040"/>
+          <p:cNvPr id="43" name="yr7"/>
+          <p:cNvSpPr txBox="1"/>
+          <p:nvPr/>
+        </p:nvSpPr>
+        <p:spPr>
+          <a:xfrm>
+            <a:off x="10364724" y="4645152"/>
+            <a:ext cx="1417320" cy="320040"/>
           </a:xfrm>
           <a:prstGeom prst="rect">
             <a:avLst/>
@@ -4162,27 +4476,27 @@
               <a:buNone/>
             </a:pPr>
             <a:r>
-              <a:rPr lang="en-US" sz="1600" b="1" dirty="0">
+              <a:rPr lang="en-US" sz="1500" b="1" dirty="0">
                 <a:solidFill>
                   <a:srgbClr val="1C1B1D"/>
                 </a:solidFill>
               </a:rPr>
               <a:t>1947</a:t>
             </a:r>
-            <a:endParaRPr lang="en-US" sz="1600" dirty="0"/>
-          </a:p>
-        </p:txBody>
-      </p:sp>
-      <p:sp>
-        <p:nvSpPr>
-          <p:cNvPr id="34" name="caption"/>
-          <p:cNvSpPr txBox="1"/>
-          <p:nvPr/>
-        </p:nvSpPr>
-        <p:spPr>
-          <a:xfrm>
-            <a:off x="9966960" y="4956048"/>
-            <a:ext cx="1755648" cy="274320"/>
+            <a:endParaRPr lang="en-US" sz="1500" dirty="0"/>
+          </a:p>
+        </p:txBody>
+      </p:sp>
+      <p:sp>
+        <p:nvSpPr>
+          <p:cNvPr id="44" name="caption"/>
+          <p:cNvSpPr txBox="1"/>
+          <p:nvPr/>
+        </p:nvSpPr>
+        <p:spPr>
+          <a:xfrm>
+            <a:off x="10364724" y="4956048"/>
+            <a:ext cx="1417320" cy="274320"/>
           </a:xfrm>
           <a:prstGeom prst="rect">
             <a:avLst/>
@@ -4198,27 +4512,27 @@
               <a:buNone/>
             </a:pPr>
             <a:r>
-              <a:rPr lang="en-US" sz="1200" dirty="0">
+              <a:rPr lang="en-US" sz="1100" dirty="0">
                 <a:solidFill>
                   <a:srgbClr val="1C1B1D"/>
                 </a:solidFill>
               </a:rPr>
               <a:t>《For Immobility》</a:t>
             </a:r>
-            <a:endParaRPr lang="en-US" sz="1200" dirty="0"/>
-          </a:p>
-        </p:txBody>
-      </p:sp>
-      <p:sp>
-        <p:nvSpPr>
-          <p:cNvPr id="35" name="caption"/>
-          <p:cNvSpPr txBox="1"/>
-          <p:nvPr/>
-        </p:nvSpPr>
-        <p:spPr>
-          <a:xfrm>
-            <a:off x="9966960" y="5212080"/>
-            <a:ext cx="1755648" cy="274320"/>
+            <a:endParaRPr lang="en-US" sz="1100" dirty="0"/>
+          </a:p>
+        </p:txBody>
+      </p:sp>
+      <p:sp>
+        <p:nvSpPr>
+          <p:cNvPr id="45" name="caption"/>
+          <p:cNvSpPr txBox="1"/>
+          <p:nvPr/>
+        </p:nvSpPr>
+        <p:spPr>
+          <a:xfrm>
+            <a:off x="10364724" y="5212080"/>
+            <a:ext cx="1417320" cy="274320"/>
           </a:xfrm>
           <a:prstGeom prst="rect">
             <a:avLst/>
@@ -4234,20 +4548,20 @@
               <a:buNone/>
             </a:pPr>
             <a:r>
-              <a:rPr lang="en-US" sz="1000" dirty="0">
+              <a:rPr lang="en-US" sz="900" dirty="0">
                 <a:solidFill>
                   <a:srgbClr val="5F5D63"/>
                 </a:solidFill>
               </a:rPr>
-              <a:t>Art Institute of Chicago</a:t>
-            </a:r>
-            <a:endParaRPr lang="en-US" sz="1000" dirty="0"/>
-          </a:p>
-        </p:txBody>
-      </p:sp>
-      <p:sp>
-        <p:nvSpPr>
-          <p:cNvPr id="36" name="body"/>
+              <a:t>AIC 249441</a:t>
+            </a:r>
+            <a:endParaRPr lang="en-US" sz="900" dirty="0"/>
+          </a:p>
+        </p:txBody>
+      </p:sp>
+      <p:sp>
+        <p:nvSpPr>
+          <p:cNvPr id="46" name="body"/>
           <p:cNvSpPr txBox="1"/>
           <p:nvPr/>
         </p:nvSpPr>
@@ -4278,7 +4592,7 @@
                   <a:srgbClr val="5F5D63"/>
                 </a:solidFill>
               </a:rPr>
-              <a:t>另有：《Dragonfly》1926（MoMA，pochoir 版畫）、《Insectes》約 1930（André Breton 舊藏）</a:t>
+              <a:t>《Insectes》裡的天牛與花潛金龜，也出現在 [Butterflies] 下緣：同一批標本</a:t>
             </a:r>
             <a:endParaRPr lang="en-US" sz="1200" dirty="0"/>
           </a:p>
@@ -4286,7 +4600,7 @@
       </p:sp>
       <p:sp>
         <p:nvSpPr>
-          <p:cNvPr id="37" name="takeaway-bar"/>
+          <p:cNvPr id="47" name="takeaway-bar"/>
           <p:cNvSpPr/>
           <p:nvPr/>
         </p:nvSpPr>
@@ -4311,7 +4625,7 @@
       </p:sp>
       <p:sp>
         <p:nvSpPr>
-          <p:cNvPr id="38" name="takeaway"/>
+          <p:cNvPr id="48" name="takeaway"/>
           <p:cNvSpPr txBox="1"/>
           <p:nvPr/>
         </p:nvSpPr>
@@ -4347,7 +4661,7 @@
       </p:sp>
       <p:sp>
         <p:nvSpPr>
-          <p:cNvPr id="39" name="source"/>
+          <p:cNvPr id="49" name="source"/>
           <p:cNvSpPr txBox="1"/>
           <p:nvPr/>
         </p:nvSpPr>
@@ -4375,7 +4689,7 @@
                   <a:srgbClr val="8A877F"/>
                 </a:solidFill>
               </a:rPr>
-              <a:t>出處：The Met 新聞稿《Man Ray: When Objects Dream》、1977.539；Centre Pompidou；研究素材 p.242；AIC 249441；MoMA 385.1988.10；André Breton 舊藏 2003 Lot 5144</a:t>
+              <a:t>出處：The Met 新聞稿、1977.539；NGA《Revolving Doors》（MoMA 385.1988.10 同版）；André Breton 舊藏 2003 Lot 5144；Centre Pompidou；研究素材 p.242；AIC 249441</a:t>
             </a:r>
             <a:endParaRPr lang="en-US" sz="900" dirty="0"/>
           </a:p>
@@ -5636,7 +5950,7 @@
         <p:spPr>
           <a:xfrm>
             <a:off x="457200" y="1325880"/>
-            <a:ext cx="3805453" cy="4709160"/>
+            <a:ext cx="3362099" cy="4160520"/>
           </a:xfrm>
           <a:prstGeom prst="rect">
             <a:avLst/>
@@ -5651,8 +5965,8 @@
         </p:nvSpPr>
         <p:spPr>
           <a:xfrm>
-            <a:off x="457200" y="6071616"/>
-            <a:ext cx="5029200" cy="320040"/>
+            <a:off x="457200" y="5522976"/>
+            <a:ext cx="4206240" cy="320040"/>
           </a:xfrm>
           <a:prstGeom prst="rect">
             <a:avLst/>
@@ -5679,16 +5993,208 @@
           </a:p>
         </p:txBody>
       </p:sp>
-      <p:sp>
-        <p:nvSpPr>
-          <p:cNvPr id="6" name="body"/>
-          <p:cNvSpPr txBox="1"/>
-          <p:nvPr/>
-        </p:nvSpPr>
-        <p:spPr>
-          <a:xfrm>
-            <a:off x="5486400" y="1463040"/>
-            <a:ext cx="6217920" cy="3291840"/>
+      <p:pic>
+        <p:nvPicPr>
+          <p:cNvPr id="6" name="Magnolia 1926" descr="/tmp/claude-0/deck12/img/mr_magnolia_1926.jpg">    </p:cNvPr>
+          <p:cNvPicPr>
+            <a:picLocks noChangeAspect="1"/>
+          </p:cNvPicPr>
+          <p:nvPr/>
+        </p:nvPicPr>
+        <p:blipFill>
+          <a:blip r:embed="rId2"/>
+          <a:stretch>
+            <a:fillRect/>
+          </a:stretch>
+        </p:blipFill>
+        <p:spPr>
+          <a:xfrm>
+            <a:off x="4709160" y="1325880"/>
+            <a:ext cx="2427593" cy="2926080"/>
+          </a:xfrm>
+          <a:prstGeom prst="rect">
+            <a:avLst/>
+          </a:prstGeom>
+        </p:spPr>
+      </p:pic>
+      <p:sp>
+        <p:nvSpPr>
+          <p:cNvPr id="7" name="caption"/>
+          <p:cNvSpPr txBox="1"/>
+          <p:nvPr/>
+        </p:nvSpPr>
+        <p:spPr>
+          <a:xfrm>
+            <a:off x="4709160" y="4288536"/>
+            <a:ext cx="3017520" cy="320040"/>
+          </a:xfrm>
+          <a:prstGeom prst="rect">
+            <a:avLst/>
+          </a:prstGeom>
+          <a:noFill/>
+          <a:ln/>
+        </p:spPr>
+        <p:txBody>
+          <a:bodyPr wrap="square" lIns="0" tIns="0" rIns="0" bIns="0" rtlCol="0" anchor="t"/>
+          <a:lstStyle/>
+          <a:p>
+            <a:pPr algn="l" indent="0" marL="0">
+              <a:buNone/>
+            </a:pPr>
+            <a:r>
+              <a:rPr lang="en-US" sz="1200" dirty="0">
+                <a:solidFill>
+                  <a:srgbClr val="5F5D63"/>
+                </a:solidFill>
+              </a:rPr>
+              <a:t>《Magnolia》1926（Phillips 2024）</a:t>
+            </a:r>
+            <a:endParaRPr lang="en-US" sz="1200" dirty="0"/>
+          </a:p>
+        </p:txBody>
+      </p:sp>
+      <p:sp>
+        <p:nvSpPr>
+          <p:cNvPr id="8" name="plus"/>
+          <p:cNvSpPr txBox="1"/>
+          <p:nvPr/>
+        </p:nvSpPr>
+        <p:spPr>
+          <a:xfrm>
+            <a:off x="7589520" y="2331720"/>
+            <a:ext cx="457200" cy="548640"/>
+          </a:xfrm>
+          <a:prstGeom prst="rect">
+            <a:avLst/>
+          </a:prstGeom>
+          <a:noFill/>
+          <a:ln/>
+        </p:spPr>
+        <p:txBody>
+          <a:bodyPr wrap="square" lIns="0" tIns="0" rIns="0" bIns="0" rtlCol="0" anchor="ctr"/>
+          <a:lstStyle/>
+          <a:p>
+            <a:pPr algn="ctr" indent="0" marL="0">
+              <a:buNone/>
+            </a:pPr>
+            <a:r>
+              <a:rPr lang="en-US" sz="2800" b="1" dirty="0">
+                <a:solidFill>
+                  <a:srgbClr val="A8321F"/>
+                </a:solidFill>
+              </a:rPr>
+              <a:t>＋</a:t>
+            </a:r>
+            <a:endParaRPr lang="en-US" sz="2800" dirty="0"/>
+          </a:p>
+        </p:txBody>
+      </p:sp>
+      <p:pic>
+        <p:nvPicPr>
+          <p:cNvPr id="9" name="Magnolia double" descr="/tmp/claude-0/deck12/img/mr_magnolia_double.jpg">    </p:cNvPr>
+          <p:cNvPicPr>
+            <a:picLocks noChangeAspect="1"/>
+          </p:cNvPicPr>
+          <p:nvPr/>
+        </p:nvPicPr>
+        <p:blipFill>
+          <a:blip r:embed="rId3"/>
+          <a:stretch>
+            <a:fillRect/>
+          </a:stretch>
+        </p:blipFill>
+        <p:spPr>
+          <a:xfrm>
+            <a:off x="8046720" y="1325880"/>
+            <a:ext cx="3657600" cy="2365248"/>
+          </a:xfrm>
+          <a:prstGeom prst="rect">
+            <a:avLst/>
+          </a:prstGeom>
+        </p:spPr>
+      </p:pic>
+      <p:sp>
+        <p:nvSpPr>
+          <p:cNvPr id="10" name="caption"/>
+          <p:cNvSpPr txBox="1"/>
+          <p:nvPr/>
+        </p:nvSpPr>
+        <p:spPr>
+          <a:xfrm>
+            <a:off x="8046720" y="3727704"/>
+            <a:ext cx="3657600" cy="320040"/>
+          </a:xfrm>
+          <a:prstGeom prst="rect">
+            <a:avLst/>
+          </a:prstGeom>
+          <a:noFill/>
+          <a:ln/>
+        </p:spPr>
+        <p:txBody>
+          <a:bodyPr wrap="square" lIns="0" tIns="0" rIns="0" bIns="0" rtlCol="0" anchor="t"/>
+          <a:lstStyle/>
+          <a:p>
+            <a:pPr algn="l" indent="0" marL="0">
+              <a:buNone/>
+            </a:pPr>
+            <a:r>
+              <a:rPr lang="en-US" sz="1200" dirty="0">
+                <a:solidFill>
+                  <a:srgbClr val="5F5D63"/>
+                </a:solidFill>
+              </a:rPr>
+              <a:t>《Magnolia（Double exposure）》1930s</a:t>
+            </a:r>
+            <a:endParaRPr lang="en-US" sz="1200" dirty="0"/>
+          </a:p>
+        </p:txBody>
+      </p:sp>
+      <p:sp>
+        <p:nvSpPr>
+          <p:cNvPr id="11" name="caption"/>
+          <p:cNvSpPr txBox="1"/>
+          <p:nvPr/>
+        </p:nvSpPr>
+        <p:spPr>
+          <a:xfrm>
+            <a:off x="8046720" y="3965448"/>
+            <a:ext cx="3657600" cy="320040"/>
+          </a:xfrm>
+          <a:prstGeom prst="rect">
+            <a:avLst/>
+          </a:prstGeom>
+          <a:noFill/>
+          <a:ln/>
+        </p:spPr>
+        <p:txBody>
+          <a:bodyPr wrap="square" lIns="0" tIns="0" rIns="0" bIns="0" rtlCol="0" anchor="t"/>
+          <a:lstStyle/>
+          <a:p>
+            <a:pPr algn="l" indent="0" marL="0">
+              <a:buNone/>
+            </a:pPr>
+            <a:r>
+              <a:rPr lang="en-US" sz="1200" dirty="0">
+                <a:solidFill>
+                  <a:srgbClr val="5F5D63"/>
+                </a:solidFill>
+              </a:rPr>
+              <a:t>木蘭花＋女性的眼睛（Sotheby’s 2017）</a:t>
+            </a:r>
+            <a:endParaRPr lang="en-US" sz="1200" dirty="0"/>
+          </a:p>
+        </p:txBody>
+      </p:sp>
+      <p:sp>
+        <p:nvSpPr>
+          <p:cNvPr id="12" name="body"/>
+          <p:cNvSpPr txBox="1"/>
+          <p:nvPr/>
+        </p:nvSpPr>
+        <p:spPr>
+          <a:xfrm>
+            <a:off x="4709160" y="4800600"/>
+            <a:ext cx="7040880" cy="822960"/>
           </a:xfrm>
           <a:prstGeom prst="rect">
             <a:avLst/>
@@ -5702,24 +6208,24 @@
           <a:p>
             <a:pPr algn="l" indent="0" marL="0">
               <a:spcAft>
-                <a:spcPts val="400"/>
+                <a:spcPts val="200"/>
               </a:spcAft>
               <a:buNone/>
             </a:pPr>
             <a:r>
-              <a:rPr lang="en-US" sz="1800" b="1" dirty="0">
+              <a:rPr lang="en-US" sz="1600" b="1" dirty="0">
                 <a:solidFill>
                   <a:srgbClr val="1C1B1D"/>
                 </a:solidFill>
               </a:rPr>
-              <a:t>印相時把兩張底片疊在一起</a:t>
-            </a:r>
-            <a:endParaRPr lang="en-US" sz="1800" dirty="0"/>
+              <a:t>木蘭花裡浮出一雙眼睛：兩張照片疊印</a:t>
+            </a:r>
+            <a:endParaRPr lang="en-US" sz="1600" dirty="0"/>
           </a:p>
           <a:p>
             <a:pPr algn="l" indent="0" marL="0">
               <a:spcAft>
-                <a:spcPts val="400"/>
+                <a:spcPts val="200"/>
               </a:spcAft>
               <a:buNone/>
             </a:pPr>
@@ -5729,89 +6235,21 @@
                   <a:srgbClr val="5F5D63"/>
                 </a:solidFill>
               </a:rPr>
-              <a:t>（MFAH 館方解說）</a:t>
-            </a:r>
-            <a:endParaRPr lang="en-US" sz="1800" dirty="0"/>
-          </a:p>
-          <a:p>
-            <a:pPr algn="l" indent="0" marL="0">
-              <a:spcAft>
-                <a:spcPts val="400"/>
-              </a:spcAft>
-              <a:buNone/>
-            </a:pPr>
-            <a:r>
-              <a:rPr lang="en-US" sz="1800" dirty="0">
-                <a:solidFill>
-                  <a:srgbClr val="1C1B1D"/>
-                </a:solidFill>
-              </a:rPr>
-              <a:t> </a:t>
-            </a:r>
-            <a:endParaRPr lang="en-US" sz="1800" dirty="0"/>
-          </a:p>
-          <a:p>
-            <a:pPr algn="l" indent="0" marL="0">
-              <a:spcAft>
-                <a:spcPts val="400"/>
-              </a:spcAft>
-              <a:buNone/>
-            </a:pPr>
-            <a:r>
-              <a:rPr lang="en-US" sz="1800" dirty="0">
-                <a:solidFill>
-                  <a:srgbClr val="1C1B1D"/>
-                </a:solidFill>
-              </a:rPr>
-              <a:t>同一時期的例子：</a:t>
-            </a:r>
-            <a:endParaRPr lang="en-US" sz="1800" dirty="0"/>
-          </a:p>
-          <a:p>
-            <a:pPr algn="l" indent="0" marL="0">
-              <a:spcAft>
-                <a:spcPts val="400"/>
-              </a:spcAft>
-              <a:buNone/>
-            </a:pPr>
-            <a:r>
-              <a:rPr lang="en-US" sz="1500" dirty="0">
-                <a:solidFill>
-                  <a:srgbClr val="1C1B1D"/>
-                </a:solidFill>
-              </a:rPr>
-              <a:t>・《Marcel Duchamp》c.1920，兩張底片疊合（BMA 1988.430）</a:t>
-            </a:r>
-            <a:endParaRPr lang="en-US" sz="1800" dirty="0"/>
-          </a:p>
-          <a:p>
-            <a:pPr algn="l" indent="0" marL="0">
-              <a:spcAft>
-                <a:spcPts val="400"/>
-              </a:spcAft>
-              <a:buNone/>
-            </a:pPr>
-            <a:r>
-              <a:rPr lang="en-US" sz="1500" dirty="0">
-                <a:solidFill>
-                  <a:srgbClr val="1C1B1D"/>
-                </a:solidFill>
-              </a:rPr>
-              <a:t>・《Magnolia（Double exposure）》：木蘭花＋女性肖像</a:t>
-            </a:r>
-            <a:endParaRPr lang="en-US" sz="1800" dirty="0"/>
-          </a:p>
-        </p:txBody>
-      </p:sp>
-      <p:sp>
-        <p:nvSpPr>
-          <p:cNvPr id="7" name="takeaway-bar"/>
+              <a:t>《Marcel Duchamp》c.1920 也是兩張底片疊合（BMA 1988.430，館方無圖）</a:t>
+            </a:r>
+            <a:endParaRPr lang="en-US" sz="1600" dirty="0"/>
+          </a:p>
+        </p:txBody>
+      </p:sp>
+      <p:sp>
+        <p:nvSpPr>
+          <p:cNvPr id="13" name="takeaway-bar"/>
           <p:cNvSpPr/>
           <p:nvPr/>
         </p:nvSpPr>
         <p:spPr>
           <a:xfrm>
-            <a:off x="5486400" y="5166360"/>
+            <a:off x="457200" y="5897880"/>
             <a:ext cx="54864" cy="347472"/>
           </a:xfrm>
           <a:prstGeom prst="rect">
@@ -5830,14 +6268,14 @@
       </p:sp>
       <p:sp>
         <p:nvSpPr>
-          <p:cNvPr id="8" name="takeaway"/>
-          <p:cNvSpPr txBox="1"/>
-          <p:nvPr/>
-        </p:nvSpPr>
-        <p:spPr>
-          <a:xfrm>
-            <a:off x="5650992" y="5120640"/>
-            <a:ext cx="6053328" cy="438912"/>
+          <p:cNvPr id="14" name="takeaway"/>
+          <p:cNvSpPr txBox="1"/>
+          <p:nvPr/>
+        </p:nvSpPr>
+        <p:spPr>
+          <a:xfrm>
+            <a:off x="621792" y="5852160"/>
+            <a:ext cx="11082528" cy="438912"/>
           </a:xfrm>
           <a:prstGeom prst="rect">
             <a:avLst/>
@@ -5866,7 +6304,7 @@
       </p:sp>
       <p:sp>
         <p:nvSpPr>
-          <p:cNvPr id="9" name="source"/>
+          <p:cNvPr id="15" name="source"/>
           <p:cNvSpPr txBox="1"/>
           <p:nvPr/>
         </p:nvSpPr>
@@ -5894,7 +6332,7 @@
                   <a:srgbClr val="8A877F"/>
                 </a:solidFill>
               </a:rPr>
-              <a:t>出處：MFAH 2015.90；Baltimore Museum of Art 1988.430；Sotheby’s 2017 Lot 118《Magnolia (Double Exposure)》</a:t>
+              <a:t>出處：MFAH 2015.90；Phillips 2024 Lot 261《Magnolia Blossom, Paris》；Sotheby’s 2017 Lot 118《Magnolia (Double Exposure)》（圖：Luminous-Lint）；BMA 1988.430</a:t>
             </a:r>
             <a:endParaRPr lang="en-US" sz="900" dirty="0"/>
           </a:p>

</xml_diff>